<commit_message>
fix(2026/templates): fix year in template
</commit_message>
<xml_diff>
--- a/2026/templates/aoscc-2026-template.pptx
+++ b/2026/templates/aoscc-2026-template.pptx
@@ -1016,7 +1016,7 @@
                   <a:ea typeface="MiSans Medium" charset="-122"/>
                   <a:cs typeface="Open Sans" pitchFamily="2" charset="0"/>
                 </a:rPr>
-                <a:t>AOSCC 2025</a:t>
+                <a:t>AOSCC 2026</a:t>
               </a:r>
               <a:endParaRPr lang="en-US" altLang="zh-CN" sz="3810" dirty="0">
                 <a:solidFill>
@@ -2628,7 +2628,7 @@
           <a:p>
             <a:r>
               <a:rPr lang="en-US"/>
-              <a:t>AOSCC 2025 </a:t>
+              <a:t>AOSCC 2026 </a:t>
             </a:r>
             <a:r>
               <a:rPr lang="zh-CN" altLang="en-US"/>
@@ -2710,7 +2710,7 @@
             </a:br>
             <a:r>
               <a:rPr lang="en-US" altLang="zh-CN"/>
-              <a:t>Core “M” </a:t>
+              <a:t>Core “N” </a:t>
             </a:r>
             <a:r>
               <a:rPr lang="zh-CN" altLang="en-US"/>

</xml_diff>